<commit_message>
add data and scripts from TJ paper OSF check data exclusion criteria in TJ paper check RT distributions with and without new exclusion
</commit_message>
<xml_diff>
--- a/progress-updates/20260609 updates.pptx
+++ b/progress-updates/20260609 updates.pptx
@@ -5,7 +5,7 @@
     <p:sldMasterId id="2147483648" r:id="rId1"/>
   </p:sldMasterIdLst>
   <p:notesMasterIdLst>
-    <p:notesMasterId r:id="rId9"/>
+    <p:notesMasterId r:id="rId12"/>
   </p:notesMasterIdLst>
   <p:sldIdLst>
     <p:sldId id="256" r:id="rId2"/>
@@ -15,6 +15,9 @@
     <p:sldId id="277" r:id="rId6"/>
     <p:sldId id="281" r:id="rId7"/>
     <p:sldId id="280" r:id="rId8"/>
+    <p:sldId id="283" r:id="rId9"/>
+    <p:sldId id="284" r:id="rId10"/>
+    <p:sldId id="282" r:id="rId11"/>
   </p:sldIdLst>
   <p:sldSz cx="12192000" cy="6858000"/>
   <p:notesSz cx="6858000" cy="9144000"/>
@@ -203,7 +206,7 @@
           <a:p>
             <a:fld id="{A9EB0D4F-7B20-C843-AEA0-6DA76DB40034}" type="datetimeFigureOut">
               <a:rPr lang="en-TW" smtClean="0"/>
-              <a:t>2026/6/5</a:t>
+              <a:t>2026/6/7</a:t>
             </a:fld>
             <a:endParaRPr lang="en-TW"/>
           </a:p>
@@ -620,7 +623,7 @@
           <a:p>
             <a:fld id="{7B32B428-AB21-474F-A4D9-979B203162CD}" type="datetimeFigureOut">
               <a:rPr lang="en-TW" smtClean="0"/>
-              <a:t>2026/6/5</a:t>
+              <a:t>2026/6/7</a:t>
             </a:fld>
             <a:endParaRPr lang="en-TW"/>
           </a:p>
@@ -820,7 +823,7 @@
           <a:p>
             <a:fld id="{7B32B428-AB21-474F-A4D9-979B203162CD}" type="datetimeFigureOut">
               <a:rPr lang="en-TW" smtClean="0"/>
-              <a:t>2026/6/5</a:t>
+              <a:t>2026/6/7</a:t>
             </a:fld>
             <a:endParaRPr lang="en-TW"/>
           </a:p>
@@ -1030,7 +1033,7 @@
           <a:p>
             <a:fld id="{7B32B428-AB21-474F-A4D9-979B203162CD}" type="datetimeFigureOut">
               <a:rPr lang="en-TW" smtClean="0"/>
-              <a:t>2026/6/5</a:t>
+              <a:t>2026/6/7</a:t>
             </a:fld>
             <a:endParaRPr lang="en-TW"/>
           </a:p>
@@ -1230,7 +1233,7 @@
           <a:p>
             <a:fld id="{7B32B428-AB21-474F-A4D9-979B203162CD}" type="datetimeFigureOut">
               <a:rPr lang="en-TW" smtClean="0"/>
-              <a:t>2026/6/5</a:t>
+              <a:t>2026/6/7</a:t>
             </a:fld>
             <a:endParaRPr lang="en-TW"/>
           </a:p>
@@ -1506,7 +1509,7 @@
           <a:p>
             <a:fld id="{7B32B428-AB21-474F-A4D9-979B203162CD}" type="datetimeFigureOut">
               <a:rPr lang="en-TW" smtClean="0"/>
-              <a:t>2026/6/5</a:t>
+              <a:t>2026/6/7</a:t>
             </a:fld>
             <a:endParaRPr lang="en-TW"/>
           </a:p>
@@ -1774,7 +1777,7 @@
           <a:p>
             <a:fld id="{7B32B428-AB21-474F-A4D9-979B203162CD}" type="datetimeFigureOut">
               <a:rPr lang="en-TW" smtClean="0"/>
-              <a:t>2026/6/5</a:t>
+              <a:t>2026/6/7</a:t>
             </a:fld>
             <a:endParaRPr lang="en-TW"/>
           </a:p>
@@ -2189,7 +2192,7 @@
           <a:p>
             <a:fld id="{7B32B428-AB21-474F-A4D9-979B203162CD}" type="datetimeFigureOut">
               <a:rPr lang="en-TW" smtClean="0"/>
-              <a:t>2026/6/5</a:t>
+              <a:t>2026/6/7</a:t>
             </a:fld>
             <a:endParaRPr lang="en-TW"/>
           </a:p>
@@ -2331,7 +2334,7 @@
           <a:p>
             <a:fld id="{7B32B428-AB21-474F-A4D9-979B203162CD}" type="datetimeFigureOut">
               <a:rPr lang="en-TW" smtClean="0"/>
-              <a:t>2026/6/5</a:t>
+              <a:t>2026/6/7</a:t>
             </a:fld>
             <a:endParaRPr lang="en-TW"/>
           </a:p>
@@ -2444,7 +2447,7 @@
           <a:p>
             <a:fld id="{7B32B428-AB21-474F-A4D9-979B203162CD}" type="datetimeFigureOut">
               <a:rPr lang="en-TW" smtClean="0"/>
-              <a:t>2026/6/5</a:t>
+              <a:t>2026/6/7</a:t>
             </a:fld>
             <a:endParaRPr lang="en-TW"/>
           </a:p>
@@ -2757,7 +2760,7 @@
           <a:p>
             <a:fld id="{7B32B428-AB21-474F-A4D9-979B203162CD}" type="datetimeFigureOut">
               <a:rPr lang="en-TW" smtClean="0"/>
-              <a:t>2026/6/5</a:t>
+              <a:t>2026/6/7</a:t>
             </a:fld>
             <a:endParaRPr lang="en-TW"/>
           </a:p>
@@ -3046,7 +3049,7 @@
           <a:p>
             <a:fld id="{7B32B428-AB21-474F-A4D9-979B203162CD}" type="datetimeFigureOut">
               <a:rPr lang="en-TW" smtClean="0"/>
-              <a:t>2026/6/5</a:t>
+              <a:t>2026/6/7</a:t>
             </a:fld>
             <a:endParaRPr lang="en-TW"/>
           </a:p>
@@ -3289,7 +3292,7 @@
           <a:p>
             <a:fld id="{7B32B428-AB21-474F-A4D9-979B203162CD}" type="datetimeFigureOut">
               <a:rPr lang="en-TW" smtClean="0"/>
-              <a:t>2026/6/5</a:t>
+              <a:t>2026/6/7</a:t>
             </a:fld>
             <a:endParaRPr lang="en-TW"/>
           </a:p>
@@ -3775,6 +3778,135 @@
 </p:sld>
 </file>
 
+<file path=ppt/slides/slide10.xml><?xml version="1.0" encoding="utf-8"?>
+<p:sld xmlns:a="http://schemas.openxmlformats.org/drawingml/2006/main" xmlns:r="http://schemas.openxmlformats.org/officeDocument/2006/relationships" xmlns:p="http://schemas.openxmlformats.org/presentationml/2006/main">
+  <p:cSld>
+    <p:spTree>
+      <p:nvGrpSpPr>
+        <p:cNvPr id="1" name=""/>
+        <p:cNvGrpSpPr/>
+        <p:nvPr/>
+      </p:nvGrpSpPr>
+      <p:grpSpPr>
+        <a:xfrm>
+          <a:off x="0" y="0"/>
+          <a:ext cx="0" cy="0"/>
+          <a:chOff x="0" y="0"/>
+          <a:chExt cx="0" cy="0"/>
+        </a:xfrm>
+      </p:grpSpPr>
+      <p:sp>
+        <p:nvSpPr>
+          <p:cNvPr id="2" name="Title 1">
+            <a:extLst>
+              <a:ext uri="{FF2B5EF4-FFF2-40B4-BE49-F238E27FC236}">
+                <a16:creationId xmlns:a16="http://schemas.microsoft.com/office/drawing/2014/main" id="{39418C76-D18F-9C1B-1192-CD6192CC87ED}"/>
+              </a:ext>
+            </a:extLst>
+          </p:cNvPr>
+          <p:cNvSpPr>
+            <a:spLocks noGrp="1"/>
+          </p:cNvSpPr>
+          <p:nvPr>
+            <p:ph type="title"/>
+          </p:nvPr>
+        </p:nvSpPr>
+        <p:spPr>
+          <a:xfrm>
+            <a:off x="0" y="0"/>
+            <a:ext cx="10515600" cy="1325563"/>
+          </a:xfrm>
+        </p:spPr>
+        <p:txBody>
+          <a:bodyPr>
+            <a:normAutofit/>
+          </a:bodyPr>
+          <a:lstStyle/>
+          <a:p>
+            <a:r>
+              <a:rPr lang="en-US" sz="4000" dirty="0"/>
+              <a:t>To-dos</a:t>
+            </a:r>
+            <a:endParaRPr lang="en-TW" sz="4000" dirty="0"/>
+          </a:p>
+        </p:txBody>
+      </p:sp>
+      <p:sp>
+        <p:nvSpPr>
+          <p:cNvPr id="10" name="Content Placeholder 2">
+            <a:extLst>
+              <a:ext uri="{FF2B5EF4-FFF2-40B4-BE49-F238E27FC236}">
+                <a16:creationId xmlns:a16="http://schemas.microsoft.com/office/drawing/2014/main" id="{A3A4D24E-F981-72B4-F9CC-00A99363702B}"/>
+              </a:ext>
+            </a:extLst>
+          </p:cNvPr>
+          <p:cNvSpPr>
+            <a:spLocks noGrp="1"/>
+          </p:cNvSpPr>
+          <p:nvPr>
+            <p:ph idx="1"/>
+          </p:nvPr>
+        </p:nvSpPr>
+        <p:spPr>
+          <a:xfrm>
+            <a:off x="92241" y="1428581"/>
+            <a:ext cx="11542295" cy="4351338"/>
+          </a:xfrm>
+        </p:spPr>
+        <p:txBody>
+          <a:bodyPr/>
+          <a:lstStyle/>
+          <a:p>
+            <a:r>
+              <a:rPr lang="en-US" dirty="0"/>
+              <a:t>Check VOT slope exclusion criteria in TJ paper</a:t>
+            </a:r>
+            <a:br>
+              <a:rPr lang="en-US" dirty="0"/>
+            </a:br>
+            <a:r>
+              <a:rPr lang="en-US" sz="2400" dirty="0"/>
+              <a:t>*see details in (TJ-OSF)section-2-methods.Rmd</a:t>
+            </a:r>
+            <a:r>
+              <a:rPr lang="en-US" dirty="0"/>
+              <a:t> </a:t>
+            </a:r>
+          </a:p>
+          <a:p>
+            <a:r>
+              <a:rPr lang="en-US" dirty="0"/>
+              <a:t>Complete 18 stimuli lists (exposure + test)</a:t>
+            </a:r>
+          </a:p>
+          <a:p>
+            <a:r>
+              <a:rPr lang="en-US" dirty="0"/>
+              <a:t>Sanity check of stimuli lists (counterbalancing and phonetic distributions)</a:t>
+            </a:r>
+            <a:endParaRPr lang="en-TW" dirty="0"/>
+          </a:p>
+          <a:p>
+            <a:pPr marL="0" indent="0">
+              <a:buNone/>
+            </a:pPr>
+            <a:endParaRPr lang="en-TW" dirty="0"/>
+          </a:p>
+        </p:txBody>
+      </p:sp>
+    </p:spTree>
+    <p:extLst>
+      <p:ext uri="{BB962C8B-B14F-4D97-AF65-F5344CB8AC3E}">
+        <p14:creationId xmlns:p14="http://schemas.microsoft.com/office/powerpoint/2010/main" val="381367419"/>
+      </p:ext>
+    </p:extLst>
+  </p:cSld>
+  <p:clrMapOvr>
+    <a:masterClrMapping/>
+  </p:clrMapOvr>
+</p:sld>
+</file>
+
 <file path=ppt/slides/slide2.xml><?xml version="1.0" encoding="utf-8"?>
 <p:sld xmlns:a="http://schemas.openxmlformats.org/drawingml/2006/main" xmlns:r="http://schemas.openxmlformats.org/officeDocument/2006/relationships" xmlns:p="http://schemas.openxmlformats.org/presentationml/2006/main">
   <p:cSld>
@@ -4929,6 +5061,387 @@
     <p:extLst>
       <p:ext uri="{BB962C8B-B14F-4D97-AF65-F5344CB8AC3E}">
         <p14:creationId xmlns:p14="http://schemas.microsoft.com/office/powerpoint/2010/main" val="790275714"/>
+      </p:ext>
+    </p:extLst>
+  </p:cSld>
+  <p:clrMapOvr>
+    <a:masterClrMapping/>
+  </p:clrMapOvr>
+</p:sld>
+</file>
+
+<file path=ppt/slides/slide8.xml><?xml version="1.0" encoding="utf-8"?>
+<p:sld xmlns:a="http://schemas.openxmlformats.org/drawingml/2006/main" xmlns:r="http://schemas.openxmlformats.org/officeDocument/2006/relationships" xmlns:p="http://schemas.openxmlformats.org/presentationml/2006/main">
+  <p:cSld>
+    <p:spTree>
+      <p:nvGrpSpPr>
+        <p:cNvPr id="1" name=""/>
+        <p:cNvGrpSpPr/>
+        <p:nvPr/>
+      </p:nvGrpSpPr>
+      <p:grpSpPr>
+        <a:xfrm>
+          <a:off x="0" y="0"/>
+          <a:ext cx="0" cy="0"/>
+          <a:chOff x="0" y="0"/>
+          <a:chExt cx="0" cy="0"/>
+        </a:xfrm>
+      </p:grpSpPr>
+      <p:sp>
+        <p:nvSpPr>
+          <p:cNvPr id="2" name="Title 1">
+            <a:extLst>
+              <a:ext uri="{FF2B5EF4-FFF2-40B4-BE49-F238E27FC236}">
+                <a16:creationId xmlns:a16="http://schemas.microsoft.com/office/drawing/2014/main" id="{39418C76-D18F-9C1B-1192-CD6192CC87ED}"/>
+              </a:ext>
+            </a:extLst>
+          </p:cNvPr>
+          <p:cNvSpPr>
+            <a:spLocks noGrp="1"/>
+          </p:cNvSpPr>
+          <p:nvPr>
+            <p:ph type="title"/>
+          </p:nvPr>
+        </p:nvSpPr>
+        <p:spPr>
+          <a:xfrm>
+            <a:off x="0" y="-48658"/>
+            <a:ext cx="10515600" cy="1325563"/>
+          </a:xfrm>
+        </p:spPr>
+        <p:txBody>
+          <a:bodyPr>
+            <a:normAutofit/>
+          </a:bodyPr>
+          <a:lstStyle/>
+          <a:p>
+            <a:r>
+              <a:rPr lang="en-US" sz="4000" dirty="0"/>
+              <a:t>Tan &amp; Jaeger (2025) – RT distribution</a:t>
+            </a:r>
+            <a:endParaRPr lang="en-TW" sz="4000" dirty="0"/>
+          </a:p>
+        </p:txBody>
+      </p:sp>
+      <p:sp>
+        <p:nvSpPr>
+          <p:cNvPr id="3" name="Content Placeholder 2">
+            <a:extLst>
+              <a:ext uri="{FF2B5EF4-FFF2-40B4-BE49-F238E27FC236}">
+                <a16:creationId xmlns:a16="http://schemas.microsoft.com/office/drawing/2014/main" id="{64BEFE99-231F-0CDA-B2BA-30185A640B78}"/>
+              </a:ext>
+            </a:extLst>
+          </p:cNvPr>
+          <p:cNvSpPr>
+            <a:spLocks noGrp="1"/>
+          </p:cNvSpPr>
+          <p:nvPr>
+            <p:ph idx="1"/>
+          </p:nvPr>
+        </p:nvSpPr>
+        <p:spPr>
+          <a:xfrm>
+            <a:off x="92241" y="1428581"/>
+            <a:ext cx="11542295" cy="4351338"/>
+          </a:xfrm>
+        </p:spPr>
+        <p:txBody>
+          <a:bodyPr/>
+          <a:lstStyle/>
+          <a:p>
+            <a:r>
+              <a:rPr lang="en-US" dirty="0"/>
+              <a:t>The exclusion criteria do not appear to be correctly implemented:</a:t>
+            </a:r>
+            <a:br>
+              <a:rPr lang="en-US" dirty="0"/>
+            </a:br>
+            <a:r>
+              <a:rPr lang="en-US" dirty="0"/>
+              <a:t>*</a:t>
+            </a:r>
+            <a:r>
+              <a:rPr lang="en-US" sz="2400" dirty="0"/>
+              <a:t>super long RT tail in the final dataset (</a:t>
+            </a:r>
+            <a:r>
+              <a:rPr lang="en-US" sz="2400" dirty="0" err="1"/>
+              <a:t>d.for_analysis</a:t>
+            </a:r>
+            <a:r>
+              <a:rPr lang="en-US" sz="2400" dirty="0"/>
+              <a:t>)!</a:t>
+            </a:r>
+            <a:endParaRPr lang="en-TW" dirty="0"/>
+          </a:p>
+        </p:txBody>
+      </p:sp>
+      <p:pic>
+        <p:nvPicPr>
+          <p:cNvPr id="7" name="Picture 6">
+            <a:extLst>
+              <a:ext uri="{FF2B5EF4-FFF2-40B4-BE49-F238E27FC236}">
+                <a16:creationId xmlns:a16="http://schemas.microsoft.com/office/drawing/2014/main" id="{9637183E-F8C2-7763-7F74-59075272D8E3}"/>
+              </a:ext>
+            </a:extLst>
+          </p:cNvPr>
+          <p:cNvPicPr>
+            <a:picLocks noChangeAspect="1"/>
+          </p:cNvPicPr>
+          <p:nvPr/>
+        </p:nvPicPr>
+        <p:blipFill>
+          <a:blip r:embed="rId2"/>
+          <a:stretch>
+            <a:fillRect/>
+          </a:stretch>
+        </p:blipFill>
+        <p:spPr>
+          <a:xfrm>
+            <a:off x="1454483" y="2659980"/>
+            <a:ext cx="8411411" cy="3770203"/>
+          </a:xfrm>
+          <a:prstGeom prst="rect">
+            <a:avLst/>
+          </a:prstGeom>
+        </p:spPr>
+      </p:pic>
+      <p:sp>
+        <p:nvSpPr>
+          <p:cNvPr id="9" name="TextBox 8">
+            <a:extLst>
+              <a:ext uri="{FF2B5EF4-FFF2-40B4-BE49-F238E27FC236}">
+                <a16:creationId xmlns:a16="http://schemas.microsoft.com/office/drawing/2014/main" id="{2A9A4975-C67D-A49A-9F1F-1C7ACB4726F6}"/>
+              </a:ext>
+            </a:extLst>
+          </p:cNvPr>
+          <p:cNvSpPr txBox="1"/>
+          <p:nvPr/>
+        </p:nvSpPr>
+        <p:spPr>
+          <a:xfrm>
+            <a:off x="6196262" y="2818764"/>
+            <a:ext cx="3441032" cy="646331"/>
+          </a:xfrm>
+          <a:prstGeom prst="rect">
+            <a:avLst/>
+          </a:prstGeom>
+          <a:noFill/>
+        </p:spPr>
+        <p:txBody>
+          <a:bodyPr wrap="square">
+            <a:spAutoFit/>
+          </a:bodyPr>
+          <a:lstStyle/>
+          <a:p>
+            <a:r>
+              <a:rPr lang="en-US" dirty="0"/>
+              <a:t>RT &gt; 3000ms: 480/25224 (0.02%)</a:t>
+            </a:r>
+            <a:br>
+              <a:rPr lang="en-US" dirty="0"/>
+            </a:br>
+            <a:r>
+              <a:rPr lang="en-US" dirty="0"/>
+              <a:t>RT &lt; 200ms: 0%</a:t>
+            </a:r>
+            <a:endParaRPr lang="en-TW" dirty="0"/>
+          </a:p>
+        </p:txBody>
+      </p:sp>
+    </p:spTree>
+    <p:extLst>
+      <p:ext uri="{BB962C8B-B14F-4D97-AF65-F5344CB8AC3E}">
+        <p14:creationId xmlns:p14="http://schemas.microsoft.com/office/powerpoint/2010/main" val="1429974961"/>
+      </p:ext>
+    </p:extLst>
+  </p:cSld>
+  <p:clrMapOvr>
+    <a:masterClrMapping/>
+  </p:clrMapOvr>
+</p:sld>
+</file>
+
+<file path=ppt/slides/slide9.xml><?xml version="1.0" encoding="utf-8"?>
+<p:sld xmlns:a="http://schemas.openxmlformats.org/drawingml/2006/main" xmlns:r="http://schemas.openxmlformats.org/officeDocument/2006/relationships" xmlns:p="http://schemas.openxmlformats.org/presentationml/2006/main">
+  <p:cSld>
+    <p:spTree>
+      <p:nvGrpSpPr>
+        <p:cNvPr id="1" name=""/>
+        <p:cNvGrpSpPr/>
+        <p:nvPr/>
+      </p:nvGrpSpPr>
+      <p:grpSpPr>
+        <a:xfrm>
+          <a:off x="0" y="0"/>
+          <a:ext cx="0" cy="0"/>
+          <a:chOff x="0" y="0"/>
+          <a:chExt cx="0" cy="0"/>
+        </a:xfrm>
+      </p:grpSpPr>
+      <p:sp>
+        <p:nvSpPr>
+          <p:cNvPr id="2" name="Title 1">
+            <a:extLst>
+              <a:ext uri="{FF2B5EF4-FFF2-40B4-BE49-F238E27FC236}">
+                <a16:creationId xmlns:a16="http://schemas.microsoft.com/office/drawing/2014/main" id="{39418C76-D18F-9C1B-1192-CD6192CC87ED}"/>
+              </a:ext>
+            </a:extLst>
+          </p:cNvPr>
+          <p:cNvSpPr>
+            <a:spLocks noGrp="1"/>
+          </p:cNvSpPr>
+          <p:nvPr>
+            <p:ph type="title"/>
+          </p:nvPr>
+        </p:nvSpPr>
+        <p:spPr>
+          <a:xfrm>
+            <a:off x="0" y="-48658"/>
+            <a:ext cx="10515600" cy="1325563"/>
+          </a:xfrm>
+        </p:spPr>
+        <p:txBody>
+          <a:bodyPr>
+            <a:normAutofit/>
+          </a:bodyPr>
+          <a:lstStyle/>
+          <a:p>
+            <a:r>
+              <a:rPr lang="en-US" sz="4000" dirty="0"/>
+              <a:t>Tan &amp; Jaeger (2025) – RT distribution (subset)</a:t>
+            </a:r>
+            <a:endParaRPr lang="en-TW" sz="4000" dirty="0"/>
+          </a:p>
+        </p:txBody>
+      </p:sp>
+      <p:sp>
+        <p:nvSpPr>
+          <p:cNvPr id="3" name="Content Placeholder 2">
+            <a:extLst>
+              <a:ext uri="{FF2B5EF4-FFF2-40B4-BE49-F238E27FC236}">
+                <a16:creationId xmlns:a16="http://schemas.microsoft.com/office/drawing/2014/main" id="{64BEFE99-231F-0CDA-B2BA-30185A640B78}"/>
+              </a:ext>
+            </a:extLst>
+          </p:cNvPr>
+          <p:cNvSpPr>
+            <a:spLocks noGrp="1"/>
+          </p:cNvSpPr>
+          <p:nvPr>
+            <p:ph idx="1"/>
+          </p:nvPr>
+        </p:nvSpPr>
+        <p:spPr>
+          <a:xfrm>
+            <a:off x="44113" y="1043565"/>
+            <a:ext cx="11542295" cy="629824"/>
+          </a:xfrm>
+        </p:spPr>
+        <p:txBody>
+          <a:bodyPr/>
+          <a:lstStyle/>
+          <a:p>
+            <a:r>
+              <a:rPr lang="en-US" dirty="0"/>
+              <a:t>Exclude trials with RT &gt; 3000ms</a:t>
+            </a:r>
+            <a:endParaRPr lang="en-TW" dirty="0"/>
+          </a:p>
+        </p:txBody>
+      </p:sp>
+      <p:pic>
+        <p:nvPicPr>
+          <p:cNvPr id="7" name="Picture 6">
+            <a:extLst>
+              <a:ext uri="{FF2B5EF4-FFF2-40B4-BE49-F238E27FC236}">
+                <a16:creationId xmlns:a16="http://schemas.microsoft.com/office/drawing/2014/main" id="{9637183E-F8C2-7763-7F74-59075272D8E3}"/>
+              </a:ext>
+            </a:extLst>
+          </p:cNvPr>
+          <p:cNvPicPr>
+            <a:picLocks noChangeAspect="1"/>
+          </p:cNvPicPr>
+          <p:nvPr/>
+        </p:nvPicPr>
+        <p:blipFill>
+          <a:blip r:embed="rId2"/>
+          <a:srcRect/>
+          <a:stretch/>
+        </p:blipFill>
+        <p:spPr>
+          <a:xfrm>
+            <a:off x="56145" y="1673389"/>
+            <a:ext cx="4857599" cy="2312100"/>
+          </a:xfrm>
+          <a:prstGeom prst="rect">
+            <a:avLst/>
+          </a:prstGeom>
+        </p:spPr>
+      </p:pic>
+      <p:pic>
+        <p:nvPicPr>
+          <p:cNvPr id="5" name="Picture 4">
+            <a:extLst>
+              <a:ext uri="{FF2B5EF4-FFF2-40B4-BE49-F238E27FC236}">
+                <a16:creationId xmlns:a16="http://schemas.microsoft.com/office/drawing/2014/main" id="{4AE2AF1C-35CA-942E-9AE2-016E2B2CEEF7}"/>
+              </a:ext>
+            </a:extLst>
+          </p:cNvPr>
+          <p:cNvPicPr>
+            <a:picLocks noChangeAspect="1"/>
+          </p:cNvPicPr>
+          <p:nvPr/>
+        </p:nvPicPr>
+        <p:blipFill>
+          <a:blip r:embed="rId3"/>
+          <a:stretch>
+            <a:fillRect/>
+          </a:stretch>
+        </p:blipFill>
+        <p:spPr>
+          <a:xfrm>
+            <a:off x="5137480" y="1986707"/>
+            <a:ext cx="6891846" cy="4125332"/>
+          </a:xfrm>
+          <a:prstGeom prst="rect">
+            <a:avLst/>
+          </a:prstGeom>
+        </p:spPr>
+      </p:pic>
+      <p:pic>
+        <p:nvPicPr>
+          <p:cNvPr id="8" name="Picture 7">
+            <a:extLst>
+              <a:ext uri="{FF2B5EF4-FFF2-40B4-BE49-F238E27FC236}">
+                <a16:creationId xmlns:a16="http://schemas.microsoft.com/office/drawing/2014/main" id="{42D857CF-A1C4-3497-4F9F-FCC0CE35759D}"/>
+              </a:ext>
+            </a:extLst>
+          </p:cNvPr>
+          <p:cNvPicPr>
+            <a:picLocks noChangeAspect="1"/>
+          </p:cNvPicPr>
+          <p:nvPr/>
+        </p:nvPicPr>
+        <p:blipFill>
+          <a:blip r:embed="rId4"/>
+          <a:stretch>
+            <a:fillRect/>
+          </a:stretch>
+        </p:blipFill>
+        <p:spPr>
+          <a:xfrm>
+            <a:off x="75341" y="4059496"/>
+            <a:ext cx="4938036" cy="2569902"/>
+          </a:xfrm>
+          <a:prstGeom prst="rect">
+            <a:avLst/>
+          </a:prstGeom>
+        </p:spPr>
+      </p:pic>
+    </p:spTree>
+    <p:extLst>
+      <p:ext uri="{BB962C8B-B14F-4D97-AF65-F5344CB8AC3E}">
+        <p14:creationId xmlns:p14="http://schemas.microsoft.com/office/powerpoint/2010/main" val="2917893610"/>
       </p:ext>
     </p:extLst>
   </p:cSld>

</xml_diff>